<commit_message>
Rebuild all packs on the standalone project models (own timelines), remove retained-unit wording, add source models
Co-Authored-By: Claude Sonnet 5.5 <noreply@anthropic.com>
Claude-Session: https://claude.ai/code/session_01Tace5U23AKexiDyfCZxMPM
</commit_message>
<xml_diff>
--- a/output/COMBINED_125M/Deck.pptx
+++ b/output/COMBINED_125M/Deck.pptx
@@ -985,34 +985,34 @@
                 <c:ptCount val="10"/>
                 <c:lvl>
                   <c:pt idx="0">
+                    <c:v>M3</c:v>
+                  </c:pt>
+                  <c:pt idx="1">
+                    <c:v>M6</c:v>
+                  </c:pt>
+                  <c:pt idx="2">
                     <c:v>M9</c:v>
                   </c:pt>
-                  <c:pt idx="1">
+                  <c:pt idx="3">
                     <c:v>M12</c:v>
                   </c:pt>
-                  <c:pt idx="2">
+                  <c:pt idx="4">
                     <c:v>M15</c:v>
                   </c:pt>
-                  <c:pt idx="3">
+                  <c:pt idx="5">
                     <c:v>M18</c:v>
                   </c:pt>
-                  <c:pt idx="4">
+                  <c:pt idx="6">
                     <c:v>M21</c:v>
                   </c:pt>
-                  <c:pt idx="5">
+                  <c:pt idx="7">
                     <c:v>M24</c:v>
                   </c:pt>
-                  <c:pt idx="6">
+                  <c:pt idx="8">
                     <c:v>M27</c:v>
                   </c:pt>
-                  <c:pt idx="7">
+                  <c:pt idx="9">
                     <c:v>M30</c:v>
-                  </c:pt>
-                  <c:pt idx="8">
-                    <c:v>M33</c:v>
-                  </c:pt>
-                  <c:pt idx="9">
-                    <c:v>M36</c:v>
                   </c:pt>
                 </c:lvl>
               </c:multiLvlStrCache>
@@ -1110,34 +1110,34 @@
                 <c:ptCount val="10"/>
                 <c:lvl>
                   <c:pt idx="0">
+                    <c:v>M3</c:v>
+                  </c:pt>
+                  <c:pt idx="1">
+                    <c:v>M6</c:v>
+                  </c:pt>
+                  <c:pt idx="2">
                     <c:v>M9</c:v>
                   </c:pt>
-                  <c:pt idx="1">
+                  <c:pt idx="3">
                     <c:v>M12</c:v>
                   </c:pt>
-                  <c:pt idx="2">
+                  <c:pt idx="4">
                     <c:v>M15</c:v>
                   </c:pt>
-                  <c:pt idx="3">
+                  <c:pt idx="5">
                     <c:v>M18</c:v>
                   </c:pt>
-                  <c:pt idx="4">
+                  <c:pt idx="6">
                     <c:v>M21</c:v>
                   </c:pt>
-                  <c:pt idx="5">
+                  <c:pt idx="7">
                     <c:v>M24</c:v>
                   </c:pt>
-                  <c:pt idx="6">
+                  <c:pt idx="8">
                     <c:v>M27</c:v>
                   </c:pt>
-                  <c:pt idx="7">
+                  <c:pt idx="9">
                     <c:v>M30</c:v>
-                  </c:pt>
-                  <c:pt idx="8">
-                    <c:v>M33</c:v>
-                  </c:pt>
-                  <c:pt idx="9">
-                    <c:v>M36</c:v>
                   </c:pt>
                 </c:lvl>
               </c:multiLvlStrCache>
@@ -1435,40 +1435,40 @@
                 <c:ptCount val="12"/>
                 <c:lvl>
                   <c:pt idx="0">
+                    <c:v>M3</c:v>
+                  </c:pt>
+                  <c:pt idx="1">
+                    <c:v>M6</c:v>
+                  </c:pt>
+                  <c:pt idx="2">
+                    <c:v>M9</c:v>
+                  </c:pt>
+                  <c:pt idx="3">
+                    <c:v>M12</c:v>
+                  </c:pt>
+                  <c:pt idx="4">
                     <c:v>M15</c:v>
                   </c:pt>
-                  <c:pt idx="1">
+                  <c:pt idx="5">
                     <c:v>M18</c:v>
                   </c:pt>
-                  <c:pt idx="2">
+                  <c:pt idx="6">
                     <c:v>M21</c:v>
                   </c:pt>
-                  <c:pt idx="3">
+                  <c:pt idx="7">
                     <c:v>M24</c:v>
                   </c:pt>
-                  <c:pt idx="4">
+                  <c:pt idx="8">
                     <c:v>M27</c:v>
                   </c:pt>
-                  <c:pt idx="5">
+                  <c:pt idx="9">
                     <c:v>M30</c:v>
                   </c:pt>
-                  <c:pt idx="6">
+                  <c:pt idx="10">
                     <c:v>M33</c:v>
                   </c:pt>
-                  <c:pt idx="7">
+                  <c:pt idx="11">
                     <c:v>M36</c:v>
-                  </c:pt>
-                  <c:pt idx="8">
-                    <c:v>M39</c:v>
-                  </c:pt>
-                  <c:pt idx="9">
-                    <c:v>M42</c:v>
-                  </c:pt>
-                  <c:pt idx="10">
-                    <c:v>M45</c:v>
-                  </c:pt>
-                  <c:pt idx="11">
-                    <c:v>M48</c:v>
                   </c:pt>
                 </c:lvl>
               </c:multiLvlStrCache>
@@ -1572,40 +1572,40 @@
                 <c:ptCount val="12"/>
                 <c:lvl>
                   <c:pt idx="0">
+                    <c:v>M3</c:v>
+                  </c:pt>
+                  <c:pt idx="1">
+                    <c:v>M6</c:v>
+                  </c:pt>
+                  <c:pt idx="2">
+                    <c:v>M9</c:v>
+                  </c:pt>
+                  <c:pt idx="3">
+                    <c:v>M12</c:v>
+                  </c:pt>
+                  <c:pt idx="4">
                     <c:v>M15</c:v>
                   </c:pt>
-                  <c:pt idx="1">
+                  <c:pt idx="5">
                     <c:v>M18</c:v>
                   </c:pt>
-                  <c:pt idx="2">
+                  <c:pt idx="6">
                     <c:v>M21</c:v>
                   </c:pt>
-                  <c:pt idx="3">
+                  <c:pt idx="7">
                     <c:v>M24</c:v>
                   </c:pt>
-                  <c:pt idx="4">
+                  <c:pt idx="8">
                     <c:v>M27</c:v>
                   </c:pt>
-                  <c:pt idx="5">
+                  <c:pt idx="9">
                     <c:v>M30</c:v>
                   </c:pt>
-                  <c:pt idx="6">
+                  <c:pt idx="10">
                     <c:v>M33</c:v>
                   </c:pt>
-                  <c:pt idx="7">
+                  <c:pt idx="11">
                     <c:v>M36</c:v>
-                  </c:pt>
-                  <c:pt idx="8">
-                    <c:v>M39</c:v>
-                  </c:pt>
-                  <c:pt idx="9">
-                    <c:v>M42</c:v>
-                  </c:pt>
-                  <c:pt idx="10">
-                    <c:v>M45</c:v>
-                  </c:pt>
-                  <c:pt idx="11">
-                    <c:v>M48</c:v>
                   </c:pt>
                 </c:lvl>
               </c:multiLvlStrCache>
@@ -1909,34 +1909,34 @@
                 <c:ptCount val="10"/>
                 <c:lvl>
                   <c:pt idx="0">
+                    <c:v>Y0</c:v>
+                  </c:pt>
+                  <c:pt idx="1">
                     <c:v>Y1</c:v>
                   </c:pt>
-                  <c:pt idx="1">
+                  <c:pt idx="2">
                     <c:v>Y2</c:v>
                   </c:pt>
-                  <c:pt idx="2">
+                  <c:pt idx="3">
                     <c:v>Y3</c:v>
                   </c:pt>
-                  <c:pt idx="3">
+                  <c:pt idx="4">
                     <c:v>Y4</c:v>
                   </c:pt>
-                  <c:pt idx="4">
+                  <c:pt idx="5">
                     <c:v>Y5</c:v>
                   </c:pt>
-                  <c:pt idx="5">
+                  <c:pt idx="6">
                     <c:v>Y6</c:v>
                   </c:pt>
-                  <c:pt idx="6">
+                  <c:pt idx="7">
                     <c:v>Y7</c:v>
                   </c:pt>
-                  <c:pt idx="7">
+                  <c:pt idx="8">
                     <c:v>Y8</c:v>
                   </c:pt>
-                  <c:pt idx="8">
+                  <c:pt idx="9">
                     <c:v>Y9</c:v>
-                  </c:pt>
-                  <c:pt idx="9">
-                    <c:v>Y10</c:v>
                   </c:pt>
                 </c:lvl>
               </c:multiLvlStrCache>
@@ -1949,34 +1949,34 @@
                 <c:formatCode>General</c:formatCode>
                 <c:ptCount val="10"/>
                 <c:pt idx="0">
-                  <c:v>-79.58228749999999</c:v>
+                  <c:v>-102.5</c:v>
                 </c:pt>
                 <c:pt idx="1">
-                  <c:v>-8.845976874999984</c:v>
+                  <c:v>33.815256250000004</c:v>
                 </c:pt>
                 <c:pt idx="2">
-                  <c:v>696.8098959375001</c:v>
+                  <c:v>408.5766453125001</c:v>
                 </c:pt>
                 <c:pt idx="3">
-                  <c:v>-504.058116875</c:v>
+                  <c:v>54.151608749999994</c:v>
                 </c:pt>
                 <c:pt idx="4">
-                  <c:v>44.046245</c:v>
+                  <c:v>-258.78064000000006</c:v>
                 </c:pt>
                 <c:pt idx="5">
-                  <c:v>85.69112249999999</c:v>
+                  <c:v>59.59256</c:v>
                 </c:pt>
                 <c:pt idx="6">
-                  <c:v>123.8726959375</c:v>
+                  <c:v>108.5588053125</c:v>
                 </c:pt>
                 <c:pt idx="7">
-                  <c:v>-40.3310626171875</c:v>
+                  <c:v>-14.037037773437518</c:v>
                 </c:pt>
                 <c:pt idx="8">
-                  <c:v>50.42190199218754</c:v>
+                  <c:v>55.22209839843755</c:v>
                 </c:pt>
                 <c:pt idx="9">
-                  <c:v>7.4231100000000065</c:v>
+                  <c:v>30.848231250000026</c:v>
                 </c:pt>
               </c:numCache>
             </c:numRef>
@@ -2034,34 +2034,34 @@
                 <c:ptCount val="10"/>
                 <c:lvl>
                   <c:pt idx="0">
+                    <c:v>Y0</c:v>
+                  </c:pt>
+                  <c:pt idx="1">
                     <c:v>Y1</c:v>
                   </c:pt>
-                  <c:pt idx="1">
+                  <c:pt idx="2">
                     <c:v>Y2</c:v>
                   </c:pt>
-                  <c:pt idx="2">
+                  <c:pt idx="3">
                     <c:v>Y3</c:v>
                   </c:pt>
-                  <c:pt idx="3">
+                  <c:pt idx="4">
                     <c:v>Y4</c:v>
                   </c:pt>
-                  <c:pt idx="4">
+                  <c:pt idx="5">
                     <c:v>Y5</c:v>
                   </c:pt>
-                  <c:pt idx="5">
+                  <c:pt idx="6">
                     <c:v>Y6</c:v>
                   </c:pt>
-                  <c:pt idx="6">
+                  <c:pt idx="7">
                     <c:v>Y7</c:v>
                   </c:pt>
-                  <c:pt idx="7">
+                  <c:pt idx="8">
                     <c:v>Y8</c:v>
                   </c:pt>
-                  <c:pt idx="8">
+                  <c:pt idx="9">
                     <c:v>Y9</c:v>
-                  </c:pt>
-                  <c:pt idx="9">
-                    <c:v>Y10</c:v>
                   </c:pt>
                 </c:lvl>
               </c:multiLvlStrCache>
@@ -2381,88 +2381,88 @@
                 <c:ptCount val="28"/>
                 <c:lvl>
                   <c:pt idx="0">
+                    <c:v>M-3</c:v>
+                  </c:pt>
+                  <c:pt idx="1">
+                    <c:v>M0</c:v>
+                  </c:pt>
+                  <c:pt idx="2">
                     <c:v>M3</c:v>
                   </c:pt>
-                  <c:pt idx="1">
+                  <c:pt idx="3">
                     <c:v>M6</c:v>
                   </c:pt>
-                  <c:pt idx="2">
+                  <c:pt idx="4">
                     <c:v>M9</c:v>
                   </c:pt>
-                  <c:pt idx="3">
+                  <c:pt idx="5">
                     <c:v>M12</c:v>
                   </c:pt>
-                  <c:pt idx="4">
+                  <c:pt idx="6">
                     <c:v>M15</c:v>
                   </c:pt>
-                  <c:pt idx="5">
+                  <c:pt idx="7">
                     <c:v>M18</c:v>
                   </c:pt>
-                  <c:pt idx="6">
+                  <c:pt idx="8">
                     <c:v>M21</c:v>
                   </c:pt>
-                  <c:pt idx="7">
+                  <c:pt idx="9">
                     <c:v>M24</c:v>
                   </c:pt>
-                  <c:pt idx="8">
+                  <c:pt idx="10">
                     <c:v>M27</c:v>
                   </c:pt>
-                  <c:pt idx="9">
+                  <c:pt idx="11">
                     <c:v>M30</c:v>
                   </c:pt>
-                  <c:pt idx="10">
+                  <c:pt idx="12">
                     <c:v>M33</c:v>
                   </c:pt>
-                  <c:pt idx="11">
+                  <c:pt idx="13">
                     <c:v>M36</c:v>
                   </c:pt>
-                  <c:pt idx="12">
+                  <c:pt idx="14">
                     <c:v>M39</c:v>
                   </c:pt>
-                  <c:pt idx="13">
+                  <c:pt idx="15">
                     <c:v>M42</c:v>
                   </c:pt>
-                  <c:pt idx="14">
+                  <c:pt idx="16">
                     <c:v>M45</c:v>
                   </c:pt>
-                  <c:pt idx="15">
+                  <c:pt idx="17">
                     <c:v>M48</c:v>
                   </c:pt>
-                  <c:pt idx="16">
+                  <c:pt idx="18">
                     <c:v>M51</c:v>
                   </c:pt>
-                  <c:pt idx="17">
+                  <c:pt idx="19">
                     <c:v>M54</c:v>
                   </c:pt>
-                  <c:pt idx="18">
+                  <c:pt idx="20">
                     <c:v>M57</c:v>
                   </c:pt>
-                  <c:pt idx="19">
+                  <c:pt idx="21">
                     <c:v>M60</c:v>
                   </c:pt>
-                  <c:pt idx="20">
+                  <c:pt idx="22">
                     <c:v>M63</c:v>
                   </c:pt>
-                  <c:pt idx="21">
+                  <c:pt idx="23">
                     <c:v>M66</c:v>
                   </c:pt>
-                  <c:pt idx="22">
+                  <c:pt idx="24">
                     <c:v>M69</c:v>
                   </c:pt>
-                  <c:pt idx="23">
+                  <c:pt idx="25">
                     <c:v>M72</c:v>
                   </c:pt>
-                  <c:pt idx="24">
+                  <c:pt idx="26">
                     <c:v>M75</c:v>
                   </c:pt>
-                  <c:pt idx="25">
+                  <c:pt idx="27">
                     <c:v>M78</c:v>
-                  </c:pt>
-                  <c:pt idx="26">
-                    <c:v>M81</c:v>
-                  </c:pt>
-                  <c:pt idx="27">
-                    <c:v>M84</c:v>
                   </c:pt>
                 </c:lvl>
               </c:multiLvlStrCache>
@@ -2639,88 +2639,88 @@
                 <c:ptCount val="28"/>
                 <c:lvl>
                   <c:pt idx="0">
+                    <c:v>M-3</c:v>
+                  </c:pt>
+                  <c:pt idx="1">
+                    <c:v>M0</c:v>
+                  </c:pt>
+                  <c:pt idx="2">
                     <c:v>M3</c:v>
                   </c:pt>
-                  <c:pt idx="1">
+                  <c:pt idx="3">
                     <c:v>M6</c:v>
                   </c:pt>
-                  <c:pt idx="2">
+                  <c:pt idx="4">
                     <c:v>M9</c:v>
                   </c:pt>
-                  <c:pt idx="3">
+                  <c:pt idx="5">
                     <c:v>M12</c:v>
                   </c:pt>
-                  <c:pt idx="4">
+                  <c:pt idx="6">
                     <c:v>M15</c:v>
                   </c:pt>
-                  <c:pt idx="5">
+                  <c:pt idx="7">
                     <c:v>M18</c:v>
                   </c:pt>
-                  <c:pt idx="6">
+                  <c:pt idx="8">
                     <c:v>M21</c:v>
                   </c:pt>
-                  <c:pt idx="7">
+                  <c:pt idx="9">
                     <c:v>M24</c:v>
                   </c:pt>
-                  <c:pt idx="8">
+                  <c:pt idx="10">
                     <c:v>M27</c:v>
                   </c:pt>
-                  <c:pt idx="9">
+                  <c:pt idx="11">
                     <c:v>M30</c:v>
                   </c:pt>
-                  <c:pt idx="10">
+                  <c:pt idx="12">
                     <c:v>M33</c:v>
                   </c:pt>
-                  <c:pt idx="11">
+                  <c:pt idx="13">
                     <c:v>M36</c:v>
                   </c:pt>
-                  <c:pt idx="12">
+                  <c:pt idx="14">
                     <c:v>M39</c:v>
                   </c:pt>
-                  <c:pt idx="13">
+                  <c:pt idx="15">
                     <c:v>M42</c:v>
                   </c:pt>
-                  <c:pt idx="14">
+                  <c:pt idx="16">
                     <c:v>M45</c:v>
                   </c:pt>
-                  <c:pt idx="15">
+                  <c:pt idx="17">
                     <c:v>M48</c:v>
                   </c:pt>
-                  <c:pt idx="16">
+                  <c:pt idx="18">
                     <c:v>M51</c:v>
                   </c:pt>
-                  <c:pt idx="17">
+                  <c:pt idx="19">
                     <c:v>M54</c:v>
                   </c:pt>
-                  <c:pt idx="18">
+                  <c:pt idx="20">
                     <c:v>M57</c:v>
                   </c:pt>
-                  <c:pt idx="19">
+                  <c:pt idx="21">
                     <c:v>M60</c:v>
                   </c:pt>
-                  <c:pt idx="20">
+                  <c:pt idx="22">
                     <c:v>M63</c:v>
                   </c:pt>
-                  <c:pt idx="21">
+                  <c:pt idx="23">
                     <c:v>M66</c:v>
                   </c:pt>
-                  <c:pt idx="22">
+                  <c:pt idx="24">
                     <c:v>M69</c:v>
                   </c:pt>
-                  <c:pt idx="23">
+                  <c:pt idx="25">
                     <c:v>M72</c:v>
                   </c:pt>
-                  <c:pt idx="24">
+                  <c:pt idx="26">
                     <c:v>M75</c:v>
                   </c:pt>
-                  <c:pt idx="25">
+                  <c:pt idx="27">
                     <c:v>M78</c:v>
-                  </c:pt>
-                  <c:pt idx="26">
-                    <c:v>M81</c:v>
-                  </c:pt>
-                  <c:pt idx="27">
-                    <c:v>M84</c:v>
                   </c:pt>
                 </c:lvl>
               </c:multiLvlStrCache>
@@ -2897,88 +2897,88 @@
                 <c:ptCount val="28"/>
                 <c:lvl>
                   <c:pt idx="0">
+                    <c:v>M-3</c:v>
+                  </c:pt>
+                  <c:pt idx="1">
+                    <c:v>M0</c:v>
+                  </c:pt>
+                  <c:pt idx="2">
                     <c:v>M3</c:v>
                   </c:pt>
-                  <c:pt idx="1">
+                  <c:pt idx="3">
                     <c:v>M6</c:v>
                   </c:pt>
-                  <c:pt idx="2">
+                  <c:pt idx="4">
                     <c:v>M9</c:v>
                   </c:pt>
-                  <c:pt idx="3">
+                  <c:pt idx="5">
                     <c:v>M12</c:v>
                   </c:pt>
-                  <c:pt idx="4">
+                  <c:pt idx="6">
                     <c:v>M15</c:v>
                   </c:pt>
-                  <c:pt idx="5">
+                  <c:pt idx="7">
                     <c:v>M18</c:v>
                   </c:pt>
-                  <c:pt idx="6">
+                  <c:pt idx="8">
                     <c:v>M21</c:v>
                   </c:pt>
-                  <c:pt idx="7">
+                  <c:pt idx="9">
                     <c:v>M24</c:v>
                   </c:pt>
-                  <c:pt idx="8">
+                  <c:pt idx="10">
                     <c:v>M27</c:v>
                   </c:pt>
-                  <c:pt idx="9">
+                  <c:pt idx="11">
                     <c:v>M30</c:v>
                   </c:pt>
-                  <c:pt idx="10">
+                  <c:pt idx="12">
                     <c:v>M33</c:v>
                   </c:pt>
-                  <c:pt idx="11">
+                  <c:pt idx="13">
                     <c:v>M36</c:v>
                   </c:pt>
-                  <c:pt idx="12">
+                  <c:pt idx="14">
                     <c:v>M39</c:v>
                   </c:pt>
-                  <c:pt idx="13">
+                  <c:pt idx="15">
                     <c:v>M42</c:v>
                   </c:pt>
-                  <c:pt idx="14">
+                  <c:pt idx="16">
                     <c:v>M45</c:v>
                   </c:pt>
-                  <c:pt idx="15">
+                  <c:pt idx="17">
                     <c:v>M48</c:v>
                   </c:pt>
-                  <c:pt idx="16">
+                  <c:pt idx="18">
                     <c:v>M51</c:v>
                   </c:pt>
-                  <c:pt idx="17">
+                  <c:pt idx="19">
                     <c:v>M54</c:v>
                   </c:pt>
-                  <c:pt idx="18">
+                  <c:pt idx="20">
                     <c:v>M57</c:v>
                   </c:pt>
-                  <c:pt idx="19">
+                  <c:pt idx="21">
                     <c:v>M60</c:v>
                   </c:pt>
-                  <c:pt idx="20">
+                  <c:pt idx="22">
                     <c:v>M63</c:v>
                   </c:pt>
-                  <c:pt idx="21">
+                  <c:pt idx="23">
                     <c:v>M66</c:v>
                   </c:pt>
-                  <c:pt idx="22">
+                  <c:pt idx="24">
                     <c:v>M69</c:v>
                   </c:pt>
-                  <c:pt idx="23">
+                  <c:pt idx="25">
                     <c:v>M72</c:v>
                   </c:pt>
-                  <c:pt idx="24">
+                  <c:pt idx="26">
                     <c:v>M75</c:v>
                   </c:pt>
-                  <c:pt idx="25">
+                  <c:pt idx="27">
                     <c:v>M78</c:v>
-                  </c:pt>
-                  <c:pt idx="26">
-                    <c:v>M81</c:v>
-                  </c:pt>
-                  <c:pt idx="27">
-                    <c:v>M84</c:v>
                   </c:pt>
                 </c:lvl>
               </c:multiLvlStrCache>
@@ -6427,7 +6427,7 @@
                 <a:ea typeface="Cambria" pitchFamily="34" charset="-122"/>
                 <a:cs typeface="Cambria" pitchFamily="34" charset="-120"/>
               </a:rPr>
-              <a:t>215 / 308</a:t>
+              <a:t>230 / 351</a:t>
             </a:r>
             <a:endParaRPr lang="en-US" sz="3000" dirty="0"/>
           </a:p>
@@ -6601,7 +6601,7 @@
                   <a:srgbClr val="6B7280"/>
                 </a:solidFill>
               </a:rPr>
-              <a:t>Source: Jalour financial model; Financial Annex, GS_Project_CF and LA_Project_CF sheets. Project years: Y1 = months 1 to 12. Excludes the 20% of units retained by Jalour.</a:t>
+              <a:t>Source: Jalour financial model; Financial Annex, GS_Project_CF and LA_Project_CF sheets. Project years: Y1 = months 1 to 12.</a:t>
             </a:r>
             <a:endParaRPr lang="en-US" sz="900" dirty="0"/>
           </a:p>
@@ -8556,7 +8556,7 @@
                   <a:srgbClr val="1B1F2A"/>
                 </a:solidFill>
               </a:rPr>
-              <a:t>Base case: the combined position is lowest at EGP 168.0 million in month 15 and turns positive in month 30.</a:t>
+              <a:t>Base case: the combined position is lowest at EGP 168.0 million in month 9 and turns positive in month 24.</a:t>
             </a:r>
             <a:endParaRPr lang="en-US" sz="1200" dirty="0"/>
           </a:p>
@@ -8610,7 +8610,7 @@
                   <a:srgbClr val="6B7280"/>
                 </a:solidFill>
               </a:rPr>
-              <a:t>Source: Jalour financial model; Financial Annex, Combined_Position and Combined_Summary sheets. Projections, not guarantees.</a:t>
+              <a:t>Source: Jalour financial model; Financial Annex, Combined_Position and Combined_Summary sheets. Months on the common calendar: Green Square launch = month 1, L'avenir launch = month 7. Projections, not guarantees.</a:t>
             </a:r>
             <a:endParaRPr lang="en-US" sz="900" dirty="0"/>
           </a:p>
@@ -11237,7 +11237,7 @@
                             <a:srgbClr val="1B1F2A"/>
                           </a:solidFill>
                         </a:rPr>
-                        <a:t>Allocation at signing; handover months 48 and 54; resale from three months later</a:t>
+                        <a:t>Allocation at signing; handover months 42 and 42; resale from three months later</a:t>
                       </a:r>
                       <a:endParaRPr lang="en-US" sz="1200" dirty="0"/>
                     </a:p>
@@ -11298,7 +11298,7 @@
                             <a:srgbClr val="1B1F2A"/>
                           </a:solidFill>
                         </a:rPr>
-                        <a:t>Grace 24 months; 12 quarterly instalments per project, months 30 to 63 and 39 to 72</a:t>
+                        <a:t>Grace 24 months; 12 quarterly instalments per project, months 24 to 57 and 27 to 60</a:t>
                       </a:r>
                       <a:endParaRPr lang="en-US" sz="1200" dirty="0"/>
                     </a:p>
@@ -12347,7 +12347,7 @@
                             <a:srgbClr val="1B1F2A"/>
                           </a:solidFill>
                         </a:rPr>
-                        <a:t>57</a:t>
+                        <a:t>51</a:t>
                       </a:r>
                       <a:endParaRPr lang="en-US" sz="1200" dirty="0"/>
                     </a:p>
@@ -12408,7 +12408,7 @@
                             <a:srgbClr val="1B1F2A"/>
                           </a:solidFill>
                         </a:rPr>
-                        <a:t>48</a:t>
+                        <a:t>42</a:t>
                       </a:r>
                       <a:endParaRPr lang="en-US" sz="1200" dirty="0"/>
                     </a:p>
@@ -13749,7 +13749,7 @@
                             <a:srgbClr val="1B1F2A"/>
                           </a:solidFill>
                         </a:rPr>
-                        <a:t>215</a:t>
+                        <a:t>230</a:t>
                       </a:r>
                       <a:endParaRPr lang="en-US" sz="1100" dirty="0"/>
                     </a:p>
@@ -13871,7 +13871,7 @@
                             <a:srgbClr val="1B1F2A"/>
                           </a:solidFill>
                         </a:rPr>
-                        <a:t>308</a:t>
+                        <a:t>351</a:t>
                       </a:r>
                       <a:endParaRPr lang="en-US" sz="1100" dirty="0"/>
                     </a:p>
@@ -14056,7 +14056,7 @@
                             <a:srgbClr val="1B1F2A"/>
                           </a:solidFill>
                         </a:rPr>
-                        <a:t>116</a:t>
+                        <a:t>124</a:t>
                       </a:r>
                       <a:endParaRPr lang="en-US" sz="1100" dirty="0"/>
                     </a:p>
@@ -14178,7 +14178,7 @@
                             <a:srgbClr val="1B1F2A"/>
                           </a:solidFill>
                         </a:rPr>
-                        <a:t>204</a:t>
+                        <a:t>232</a:t>
                       </a:r>
                       <a:endParaRPr lang="en-US" sz="1100" dirty="0"/>
                     </a:p>
@@ -14363,7 +14363,7 @@
                             <a:srgbClr val="1B1F2A"/>
                           </a:solidFill>
                         </a:rPr>
-                        <a:t>315</a:t>
+                        <a:t>336</a:t>
                       </a:r>
                       <a:endParaRPr lang="en-US" sz="1100" dirty="0"/>
                     </a:p>
@@ -14485,7 +14485,7 @@
                             <a:srgbClr val="1B1F2A"/>
                           </a:solidFill>
                         </a:rPr>
-                        <a:t>412</a:t>
+                        <a:t>469</a:t>
                       </a:r>
                       <a:endParaRPr lang="en-US" sz="1100" dirty="0"/>
                     </a:p>
@@ -14670,7 +14670,7 @@
                             <a:srgbClr val="1B1F2A"/>
                           </a:solidFill>
                         </a:rPr>
-                        <a:t>49</a:t>
+                        <a:t>52</a:t>
                       </a:r>
                       <a:endParaRPr lang="en-US" sz="1100" dirty="0"/>
                     </a:p>
@@ -14792,7 +14792,7 @@
                             <a:srgbClr val="1B1F2A"/>
                           </a:solidFill>
                         </a:rPr>
-                        <a:t>126</a:t>
+                        <a:t>143</a:t>
                       </a:r>
                       <a:endParaRPr lang="en-US" sz="1100" dirty="0"/>
                     </a:p>
@@ -14977,7 +14977,7 @@
                             <a:srgbClr val="1B1F2A"/>
                           </a:solidFill>
                         </a:rPr>
-                        <a:t>162</a:t>
+                        <a:t>173</a:t>
                       </a:r>
                       <a:endParaRPr lang="en-US" sz="1100" dirty="0"/>
                     </a:p>
@@ -15099,7 +15099,7 @@
                             <a:srgbClr val="1B1F2A"/>
                           </a:solidFill>
                         </a:rPr>
-                        <a:t>258</a:t>
+                        <a:t>294</a:t>
                       </a:r>
                       <a:endParaRPr lang="en-US" sz="1100" dirty="0"/>
                     </a:p>
@@ -15284,7 +15284,7 @@
                             <a:srgbClr val="1B1F2A"/>
                           </a:solidFill>
                         </a:rPr>
-                        <a:t>125</a:t>
+                        <a:t>134</a:t>
                       </a:r>
                       <a:endParaRPr lang="en-US" sz="1100" dirty="0"/>
                     </a:p>
@@ -15406,7 +15406,7 @@
                             <a:srgbClr val="1B1F2A"/>
                           </a:solidFill>
                         </a:rPr>
-                        <a:t>209</a:t>
+                        <a:t>239</a:t>
                       </a:r>
                       <a:endParaRPr lang="en-US" sz="1100" dirty="0"/>
                     </a:p>
@@ -15591,7 +15591,7 @@
                             <a:srgbClr val="1B1F2A"/>
                           </a:solidFill>
                         </a:rPr>
-                        <a:t>155</a:t>
+                        <a:t>166</a:t>
                       </a:r>
                       <a:endParaRPr lang="en-US" sz="1100" dirty="0"/>
                     </a:p>
@@ -15713,7 +15713,7 @@
                             <a:srgbClr val="1B1F2A"/>
                           </a:solidFill>
                         </a:rPr>
-                        <a:t>275</a:t>
+                        <a:t>313</a:t>
                       </a:r>
                       <a:endParaRPr lang="en-US" sz="1100" dirty="0"/>
                     </a:p>
@@ -17409,7 +17409,7 @@
         </p:nvSpPr>
         <p:spPr>
           <a:xfrm>
-            <a:off x="2643319" y="1929384"/>
+            <a:off x="2694522" y="1929384"/>
             <a:ext cx="164592" cy="164592"/>
           </a:xfrm>
           <a:prstGeom prst="ellipse">
@@ -17434,7 +17434,7 @@
         </p:nvSpPr>
         <p:spPr>
           <a:xfrm>
-            <a:off x="2085535" y="1143000"/>
+            <a:off x="2136738" y="1143000"/>
             <a:ext cx="1280160" cy="731520"/>
           </a:xfrm>
           <a:prstGeom prst="rect">
@@ -17470,7 +17470,7 @@
                   <a:srgbClr val="1B1F2A"/>
                 </a:solidFill>
               </a:rPr>
-              <a:t>Month 3</a:t>
+              <a:t>Month -3</a:t>
             </a:r>
             <a:endParaRPr lang="en-US" sz="1000" dirty="0"/>
           </a:p>
@@ -17484,7 +17484,7 @@
         </p:nvSpPr>
         <p:spPr>
           <a:xfrm>
-            <a:off x="3107553" y="1929384"/>
+            <a:off x="3227025" y="1929384"/>
             <a:ext cx="164592" cy="164592"/>
           </a:xfrm>
           <a:prstGeom prst="ellipse">
@@ -17509,7 +17509,7 @@
         </p:nvSpPr>
         <p:spPr>
           <a:xfrm>
-            <a:off x="2549769" y="2148840"/>
+            <a:off x="2669241" y="2148840"/>
             <a:ext cx="1280160" cy="731520"/>
           </a:xfrm>
           <a:prstGeom prst="rect">
@@ -17545,7 +17545,7 @@
                   <a:srgbClr val="1B1F2A"/>
                 </a:solidFill>
               </a:rPr>
-              <a:t>Month 7</a:t>
+              <a:t>Month 1</a:t>
             </a:r>
             <a:endParaRPr lang="en-US" sz="1000" dirty="0"/>
           </a:p>
@@ -17559,7 +17559,7 @@
         </p:nvSpPr>
         <p:spPr>
           <a:xfrm>
-            <a:off x="3803904" y="1929384"/>
+            <a:off x="4025780" y="1929384"/>
             <a:ext cx="164592" cy="164592"/>
           </a:xfrm>
           <a:prstGeom prst="ellipse">
@@ -17584,7 +17584,7 @@
         </p:nvSpPr>
         <p:spPr>
           <a:xfrm>
-            <a:off x="3246120" y="1143000"/>
+            <a:off x="3467996" y="1143000"/>
             <a:ext cx="1280160" cy="731520"/>
           </a:xfrm>
           <a:prstGeom prst="rect">
@@ -17620,7 +17620,7 @@
                   <a:srgbClr val="1B1F2A"/>
                 </a:solidFill>
               </a:rPr>
-              <a:t>Month 13</a:t>
+              <a:t>Month 7</a:t>
             </a:r>
             <a:endParaRPr lang="en-US" sz="1000" dirty="0"/>
           </a:p>
@@ -17634,7 +17634,7 @@
         </p:nvSpPr>
         <p:spPr>
           <a:xfrm>
-            <a:off x="5776898" y="1929384"/>
+            <a:off x="6288920" y="1929384"/>
             <a:ext cx="164592" cy="164592"/>
           </a:xfrm>
           <a:prstGeom prst="ellipse">
@@ -17659,7 +17659,7 @@
         </p:nvSpPr>
         <p:spPr>
           <a:xfrm>
-            <a:off x="5219114" y="2148840"/>
+            <a:off x="5731136" y="2148840"/>
             <a:ext cx="1280160" cy="731520"/>
           </a:xfrm>
           <a:prstGeom prst="rect">
@@ -17695,7 +17695,7 @@
                   <a:srgbClr val="1B1F2A"/>
                 </a:solidFill>
               </a:rPr>
-              <a:t>Month 30</a:t>
+              <a:t>Month 24</a:t>
             </a:r>
             <a:endParaRPr lang="en-US" sz="1000" dirty="0"/>
           </a:p>
@@ -17709,7 +17709,7 @@
         </p:nvSpPr>
         <p:spPr>
           <a:xfrm>
-            <a:off x="7865950" y="1929384"/>
+            <a:off x="8685186" y="1929384"/>
             <a:ext cx="164592" cy="164592"/>
           </a:xfrm>
           <a:prstGeom prst="ellipse">
@@ -17734,7 +17734,7 @@
         </p:nvSpPr>
         <p:spPr>
           <a:xfrm>
-            <a:off x="7308166" y="1143000"/>
+            <a:off x="8127402" y="1143000"/>
             <a:ext cx="1280160" cy="731520"/>
           </a:xfrm>
           <a:prstGeom prst="rect">
@@ -17770,7 +17770,7 @@
                   <a:srgbClr val="1B1F2A"/>
                 </a:solidFill>
               </a:rPr>
-              <a:t>Month 48</a:t>
+              <a:t>Month 42</a:t>
             </a:r>
             <a:endParaRPr lang="en-US" sz="1000" dirty="0"/>
           </a:p>
@@ -17784,7 +17784,7 @@
         </p:nvSpPr>
         <p:spPr>
           <a:xfrm>
-            <a:off x="9606827" y="1929384"/>
+            <a:off x="10682075" y="1929384"/>
             <a:ext cx="164592" cy="164592"/>
           </a:xfrm>
           <a:prstGeom prst="ellipse">
@@ -17809,7 +17809,7 @@
         </p:nvSpPr>
         <p:spPr>
           <a:xfrm>
-            <a:off x="9049043" y="2148840"/>
+            <a:off x="10124291" y="2148840"/>
             <a:ext cx="1280160" cy="731520"/>
           </a:xfrm>
           <a:prstGeom prst="rect">
@@ -17845,7 +17845,7 @@
                   <a:srgbClr val="1B1F2A"/>
                 </a:solidFill>
               </a:rPr>
-              <a:t>Month 63</a:t>
+              <a:t>Month 57</a:t>
             </a:r>
             <a:endParaRPr lang="en-US" sz="1000" dirty="0"/>
           </a:p>
@@ -17918,7 +17918,7 @@
         </p:nvSpPr>
         <p:spPr>
           <a:xfrm>
-            <a:off x="3687846" y="3941064"/>
+            <a:off x="3093899" y="3941064"/>
             <a:ext cx="164592" cy="164592"/>
           </a:xfrm>
           <a:prstGeom prst="ellipse">
@@ -17943,7 +17943,7 @@
         </p:nvSpPr>
         <p:spPr>
           <a:xfrm>
-            <a:off x="3130062" y="3154680"/>
+            <a:off x="2536115" y="3154680"/>
             <a:ext cx="1280160" cy="731520"/>
           </a:xfrm>
           <a:prstGeom prst="rect">
@@ -17979,7 +17979,7 @@
                   <a:srgbClr val="1B1F2A"/>
                 </a:solidFill>
               </a:rPr>
-              <a:t>Month 12</a:t>
+              <a:t>Month 0</a:t>
             </a:r>
             <a:endParaRPr lang="en-US" sz="1000" dirty="0"/>
           </a:p>
@@ -17993,7 +17993,7 @@
         </p:nvSpPr>
         <p:spPr>
           <a:xfrm>
-            <a:off x="3803904" y="3941064"/>
+            <a:off x="3227025" y="3941064"/>
             <a:ext cx="164592" cy="164592"/>
           </a:xfrm>
           <a:prstGeom prst="ellipse">
@@ -18018,7 +18018,7 @@
         </p:nvSpPr>
         <p:spPr>
           <a:xfrm>
-            <a:off x="3246120" y="4160520"/>
+            <a:off x="2669241" y="4160520"/>
             <a:ext cx="1280160" cy="731520"/>
           </a:xfrm>
           <a:prstGeom prst="rect">
@@ -18054,7 +18054,7 @@
                   <a:srgbClr val="1B1F2A"/>
                 </a:solidFill>
               </a:rPr>
-              <a:t>Month 13</a:t>
+              <a:t>Month 1</a:t>
             </a:r>
             <a:endParaRPr lang="en-US" sz="1000" dirty="0"/>
           </a:p>
@@ -18068,7 +18068,7 @@
         </p:nvSpPr>
         <p:spPr>
           <a:xfrm>
-            <a:off x="4500255" y="3941064"/>
+            <a:off x="4025780" y="3941064"/>
             <a:ext cx="164592" cy="164592"/>
           </a:xfrm>
           <a:prstGeom prst="ellipse">
@@ -18093,7 +18093,7 @@
         </p:nvSpPr>
         <p:spPr>
           <a:xfrm>
-            <a:off x="3942471" y="3154680"/>
+            <a:off x="3467996" y="3154680"/>
             <a:ext cx="1280160" cy="731520"/>
           </a:xfrm>
           <a:prstGeom prst="rect">
@@ -18129,7 +18129,7 @@
                   <a:srgbClr val="1B1F2A"/>
                 </a:solidFill>
               </a:rPr>
-              <a:t>Month 19</a:t>
+              <a:t>Month 7</a:t>
             </a:r>
             <a:endParaRPr lang="en-US" sz="1000" dirty="0"/>
           </a:p>
@@ -18143,7 +18143,7 @@
         </p:nvSpPr>
         <p:spPr>
           <a:xfrm>
-            <a:off x="6821424" y="3941064"/>
+            <a:off x="6688298" y="3941064"/>
             <a:ext cx="164592" cy="164592"/>
           </a:xfrm>
           <a:prstGeom prst="ellipse">
@@ -18168,7 +18168,7 @@
         </p:nvSpPr>
         <p:spPr>
           <a:xfrm>
-            <a:off x="6263640" y="4160520"/>
+            <a:off x="6130514" y="4160520"/>
             <a:ext cx="1280160" cy="731520"/>
           </a:xfrm>
           <a:prstGeom prst="rect">
@@ -18204,7 +18204,7 @@
                   <a:srgbClr val="1B1F2A"/>
                 </a:solidFill>
               </a:rPr>
-              <a:t>Month 39</a:t>
+              <a:t>Month 27</a:t>
             </a:r>
             <a:endParaRPr lang="en-US" sz="1000" dirty="0"/>
           </a:p>
@@ -18218,7 +18218,7 @@
         </p:nvSpPr>
         <p:spPr>
           <a:xfrm>
-            <a:off x="8562301" y="3941064"/>
+            <a:off x="8685186" y="3941064"/>
             <a:ext cx="164592" cy="164592"/>
           </a:xfrm>
           <a:prstGeom prst="ellipse">
@@ -18243,7 +18243,7 @@
         </p:nvSpPr>
         <p:spPr>
           <a:xfrm>
-            <a:off x="8004517" y="3154680"/>
+            <a:off x="8127402" y="3154680"/>
             <a:ext cx="1280160" cy="731520"/>
           </a:xfrm>
           <a:prstGeom prst="rect">
@@ -18279,7 +18279,7 @@
                   <a:srgbClr val="1B1F2A"/>
                 </a:solidFill>
               </a:rPr>
-              <a:t>Month 54</a:t>
+              <a:t>Month 42</a:t>
             </a:r>
             <a:endParaRPr lang="en-US" sz="1000" dirty="0"/>
           </a:p>
@@ -18293,7 +18293,7 @@
         </p:nvSpPr>
         <p:spPr>
           <a:xfrm>
-            <a:off x="10651353" y="3941064"/>
+            <a:off x="11081452" y="3941064"/>
             <a:ext cx="164592" cy="164592"/>
           </a:xfrm>
           <a:prstGeom prst="ellipse">
@@ -18318,7 +18318,7 @@
         </p:nvSpPr>
         <p:spPr>
           <a:xfrm>
-            <a:off x="10093569" y="4160520"/>
+            <a:off x="10523668" y="4160520"/>
             <a:ext cx="1280160" cy="731520"/>
           </a:xfrm>
           <a:prstGeom prst="rect">
@@ -18354,7 +18354,7 @@
                   <a:srgbClr val="1B1F2A"/>
                 </a:solidFill>
               </a:rPr>
-              <a:t>Month 72</a:t>
+              <a:t>Month 60</a:t>
             </a:r>
             <a:endParaRPr lang="en-US" sz="1000" dirty="0"/>
           </a:p>
@@ -18394,7 +18394,7 @@
                   <a:srgbClr val="1B1F2A"/>
                 </a:solidFill>
               </a:rPr>
-              <a:t>Funding: Green Square in month 3 and L'avenir in month 12, each when the down payment falls due.</a:t>
+              <a:t>Funding: Green Square in month -3 and L'avenir in month 0, each when the landlord down payment falls due. Months are counted on each project's own timeline (month 1 = its sales launch).</a:t>
             </a:r>
             <a:endParaRPr lang="en-US" sz="1200" dirty="0"/>
           </a:p>
@@ -19366,7 +19366,7 @@
                 <a:ea typeface="Cambria" pitchFamily="34" charset="-122"/>
                 <a:cs typeface="Cambria" pitchFamily="34" charset="-120"/>
               </a:rPr>
-              <a:t>M48 and M54</a:t>
+              <a:t>M42 and M42</a:t>
             </a:r>
             <a:endParaRPr lang="en-US" sz="3000" dirty="0"/>
           </a:p>
@@ -19504,7 +19504,7 @@
                   <a:srgbClr val="6B7280"/>
                 </a:solidFill>
               </a:rPr>
-              <a:t>Combined sales plan: 80% of units sold, at modelled prices</a:t>
+              <a:t>Combined sales plan, at modelled prices</a:t>
             </a:r>
             <a:endParaRPr lang="en-US" sz="1200" dirty="0"/>
           </a:p>
@@ -23187,7 +23187,7 @@
                   <a:srgbClr val="6B7280"/>
                 </a:solidFill>
               </a:rPr>
-              <a:t>Source: Property Finder listings (2026); JLL via Enterprise (2026); Sands of Wealth (2026); CBE via Bnok24; CAPMAS via Ahram Online; Daily News Egypt. Listings are asking prices, not transactions. Model timeline assumed to start December 2026.</a:t>
+              <a:t>Source: Property Finder listings (2026); JLL via Enterprise (2026); Sands of Wealth (2026); CBE via Bnok24; CAPMAS via Ahram Online; Daily News Egypt. Listings are asking prices, not transactions. Pricing growth is measured from today (assumed December 2026).</a:t>
             </a:r>
             <a:endParaRPr lang="en-US" sz="900" dirty="0"/>
           </a:p>
@@ -24887,7 +24887,7 @@
                             <a:srgbClr val="1B1F2A"/>
                           </a:solidFill>
                         </a:rPr>
-                        <a:t>Month 7</a:t>
+                        <a:t>Month 1</a:t>
                       </a:r>
                       <a:endParaRPr lang="en-US" sz="1200" dirty="0"/>
                     </a:p>
@@ -24948,7 +24948,7 @@
                             <a:srgbClr val="1B1F2A"/>
                           </a:solidFill>
                         </a:rPr>
-                        <a:t>Month 13</a:t>
+                        <a:t>Month 1</a:t>
                       </a:r>
                       <a:endParaRPr lang="en-US" sz="1200" dirty="0"/>
                     </a:p>
@@ -25072,7 +25072,7 @@
                             <a:srgbClr val="1B1F2A"/>
                           </a:solidFill>
                         </a:rPr>
-                        <a:t>Months 13 to 48</a:t>
+                        <a:t>Months 7 to 42</a:t>
                       </a:r>
                       <a:endParaRPr lang="en-US" sz="1200" dirty="0"/>
                     </a:p>
@@ -25133,7 +25133,7 @@
                             <a:srgbClr val="1B1F2A"/>
                           </a:solidFill>
                         </a:rPr>
-                        <a:t>Months 19 to 54</a:t>
+                        <a:t>Months 7 to 42</a:t>
                       </a:r>
                       <a:endParaRPr lang="en-US" sz="1200" dirty="0"/>
                     </a:p>
@@ -25257,7 +25257,7 @@
                             <a:srgbClr val="1B1F2A"/>
                           </a:solidFill>
                         </a:rPr>
-                        <a:t>Month 48</a:t>
+                        <a:t>Month 42</a:t>
                       </a:r>
                       <a:endParaRPr lang="en-US" sz="1200" dirty="0"/>
                     </a:p>
@@ -25318,7 +25318,7 @@
                             <a:srgbClr val="1B1F2A"/>
                           </a:solidFill>
                         </a:rPr>
-                        <a:t>Month 54</a:t>
+                        <a:t>Month 42</a:t>
                       </a:r>
                       <a:endParaRPr lang="en-US" sz="1200" dirty="0"/>
                     </a:p>
@@ -25416,7 +25416,7 @@
                   <a:srgbClr val="6B7280"/>
                 </a:solidFill>
               </a:rPr>
-              <a:t>Source: Jalour financial model (project summaries). Jalour retains 20% of units in each project, outside the sales plans and outside this offering.</a:t>
+              <a:t>Source: Jalour financial model (project summaries).</a:t>
             </a:r>
             <a:endParaRPr lang="en-US" sz="900" dirty="0"/>
           </a:p>
@@ -26815,7 +26815,7 @@
                             <a:srgbClr val="FFFFFF"/>
                           </a:solidFill>
                         </a:rPr>
-                        <a:t>Total sales at 100% / 80% (EGP m)</a:t>
+                        <a:t>Sales plan (EGP m)</a:t>
                       </a:r>
                       <a:endParaRPr lang="en-US" sz="1200" dirty="0"/>
                     </a:p>
@@ -27183,7 +27183,7 @@
                             <a:srgbClr val="1B1F2A"/>
                           </a:solidFill>
                         </a:rPr>
-                        <a:t>2,816 / 2,253</a:t>
+                        <a:t>2,253</a:t>
                       </a:r>
                       <a:endParaRPr lang="en-US" sz="1200" dirty="0"/>
                     </a:p>
@@ -27551,7 +27551,7 @@
                             <a:srgbClr val="1B1F2A"/>
                           </a:solidFill>
                         </a:rPr>
-                        <a:t>3,342 / 2,674</a:t>
+                        <a:t>2,674</a:t>
                       </a:r>
                       <a:endParaRPr lang="en-US" sz="1200" dirty="0"/>
                     </a:p>

</xml_diff>